<commit_message>
Render box diagrams with Graphviz (clean arrow routing)
The matplotlib architecture/hybrid/CNN diagrams had ugly center-to-center
arrows overlapping boxes. Switched those three to Graphviz (polyline
routing, edge-to-edge connectors); signal plots (PQRST, beat window) stay
in matplotlib. Rebuilt thesis .docx and defense .pptx with the new figures.

https://claude.ai/code/session_01S5qNwg7X8K6zJLh7vUsNoh
</commit_message>
<xml_diff>
--- a/thesis/Презентація_захист_Макаренко.pptx
+++ b/thesis/Презентація_захист_Макаренко.pptx
@@ -5131,8 +5131,8 @@
         </p:blipFill>
         <p:spPr>
           <a:xfrm>
-            <a:off x="623130" y="1097280"/>
-            <a:ext cx="7349099" cy="5486400"/>
+            <a:off x="1126595" y="1097280"/>
+            <a:ext cx="6342170" cy="5486400"/>
           </a:xfrm>
           <a:prstGeom prst="rect">
             <a:avLst/>
@@ -5635,8 +5635,8 @@
         </p:blipFill>
         <p:spPr>
           <a:xfrm>
-            <a:off x="982613" y="1143000"/>
-            <a:ext cx="6447253" cy="3291840"/>
+            <a:off x="365760" y="2232885"/>
+            <a:ext cx="7680960" cy="1112069"/>
           </a:xfrm>
           <a:prstGeom prst="rect">
             <a:avLst/>

</xml_diff>